<commit_message>
feat(banners): v2 — proper figlet art, IR spectrum, boot sequence, minimal
Co-Authored-By: Claude Sonnet 4.6 <noreply@anthropic.com>
</commit_message>
<xml_diff>
--- a/presentation/banners/title_banners.pptx
+++ b/presentation/banners/title_banners.pptx
@@ -3107,8 +3107,8 @@
         </p:nvSpPr>
         <p:spPr>
           <a:xfrm>
-            <a:off x="457200" y="228600"/>
-            <a:ext cx="3657600" cy="274320"/>
+            <a:off x="457200" y="201168"/>
+            <a:ext cx="7315200" cy="274320"/>
           </a:xfrm>
           <a:prstGeom prst="rect">
             <a:avLst/>
@@ -3122,7 +3122,7 @@
           <a:lstStyle/>
           <a:p>
             <a:pPr>
-              <a:defRPr sz="1100">
+              <a:defRPr sz="1000">
                 <a:solidFill>
                   <a:srgbClr val="8B949E"/>
                 </a:solidFill>
@@ -3130,7 +3130,7 @@
               </a:defRPr>
             </a:pPr>
             <a:r>
-              <a:t>style 1 — minimal</a:t>
+              <a:t>// style 1 — figlet doom — MACE block letters</a:t>
             </a:r>
           </a:p>
         </p:txBody>
@@ -3143,8 +3143,8 @@
         </p:nvSpPr>
         <p:spPr>
           <a:xfrm>
-            <a:off x="914400" y="2560320"/>
-            <a:ext cx="7315200" cy="1371600"/>
+            <a:off x="548640" y="914400"/>
+            <a:ext cx="8412480" cy="2560320"/>
           </a:xfrm>
           <a:prstGeom prst="rect">
             <a:avLst/>
@@ -3161,7 +3161,7 @@
               <a:spcAft>
                 <a:spcPts val="0"/>
               </a:spcAft>
-              <a:defRPr sz="2800">
+              <a:defRPr sz="1600">
                 <a:solidFill>
                   <a:srgbClr val="58A6FF"/>
                 </a:solidFill>
@@ -3169,7 +3169,7 @@
               </a:defRPr>
             </a:pPr>
             <a:r>
-              <a:t>$ ./presentation.sh</a:t>
+              <a:t>___  ___  ___  _____  _____ </a:t>
             </a:r>
           </a:p>
           <a:p>
@@ -3177,20 +3177,110 @@
               <a:spcAft>
                 <a:spcPts val="0"/>
               </a:spcAft>
-              <a:defRPr sz="2800">
-                <a:solidFill>
-                  <a:srgbClr val="8B949E"/>
-                </a:solidFill>
-                <a:latin typeface="Consolas"/>
-              </a:defRPr>
-            </a:pPr>
+              <a:defRPr sz="1600">
+                <a:solidFill>
+                  <a:srgbClr val="58A6FF"/>
+                </a:solidFill>
+                <a:latin typeface="Consolas"/>
+              </a:defRPr>
+            </a:pPr>
+            <a:r>
+              <a:t>|  \/  | / _ \/  __ \|  ___|</a:t>
+            </a:r>
           </a:p>
           <a:p>
             <a:pPr algn="ctr">
               <a:spcAft>
                 <a:spcPts val="0"/>
               </a:spcAft>
-              <a:defRPr sz="2800">
+              <a:defRPr sz="1600">
+                <a:solidFill>
+                  <a:srgbClr val="58A6FF"/>
+                </a:solidFill>
+                <a:latin typeface="Consolas"/>
+              </a:defRPr>
+            </a:pPr>
+            <a:r>
+              <a:t>| .  . |/ /_\ \ /  \/| |__  </a:t>
+            </a:r>
+          </a:p>
+          <a:p>
+            <a:pPr algn="ctr">
+              <a:spcAft>
+                <a:spcPts val="0"/>
+              </a:spcAft>
+              <a:defRPr sz="1600">
+                <a:solidFill>
+                  <a:srgbClr val="58A6FF"/>
+                </a:solidFill>
+                <a:latin typeface="Consolas"/>
+              </a:defRPr>
+            </a:pPr>
+            <a:r>
+              <a:t>| |\/| ||  _  | |    |  __| </a:t>
+            </a:r>
+          </a:p>
+          <a:p>
+            <a:pPr algn="ctr">
+              <a:spcAft>
+                <a:spcPts val="0"/>
+              </a:spcAft>
+              <a:defRPr sz="1600">
+                <a:solidFill>
+                  <a:srgbClr val="58A6FF"/>
+                </a:solidFill>
+                <a:latin typeface="Consolas"/>
+              </a:defRPr>
+            </a:pPr>
+            <a:r>
+              <a:t>| |  | || | | | \__/\| |___ </a:t>
+            </a:r>
+          </a:p>
+          <a:p>
+            <a:pPr algn="ctr">
+              <a:spcAft>
+                <a:spcPts val="0"/>
+              </a:spcAft>
+              <a:defRPr sz="1600">
+                <a:solidFill>
+                  <a:srgbClr val="58A6FF"/>
+                </a:solidFill>
+                <a:latin typeface="Consolas"/>
+              </a:defRPr>
+            </a:pPr>
+            <a:r>
+              <a:t>\_|  |_/\_| |_/\____/\____/ </a:t>
+            </a:r>
+          </a:p>
+        </p:txBody>
+      </p:sp>
+      <p:sp>
+        <p:nvSpPr>
+          <p:cNvPr id="4" name="TextBox 3"/>
+          <p:cNvSpPr txBox="1"/>
+          <p:nvPr/>
+        </p:nvSpPr>
+        <p:spPr>
+          <a:xfrm>
+            <a:off x="731520" y="3749039"/>
+            <a:ext cx="7680960" cy="1828800"/>
+          </a:xfrm>
+          <a:prstGeom prst="rect">
+            <a:avLst/>
+          </a:prstGeom>
+          <a:noFill/>
+        </p:spPr>
+        <p:txBody>
+          <a:bodyPr wrap="none">
+            <a:spAutoFit/>
+          </a:bodyPr>
+          <a:lstStyle/>
+          <a:p>
+            <a:pPr algn="ctr">
+              <a:spcAft>
+                <a:spcPts val="0"/>
+              </a:spcAft>
+              <a:defRPr sz="1600">
                 <a:solidFill>
                   <a:srgbClr val="8B949E"/>
                 </a:solidFill>
@@ -3198,14 +3288,88 @@
               </a:defRPr>
             </a:pPr>
             <a:r>
+              <a:t>────────────────────────────────────────────</a:t>
+            </a:r>
+          </a:p>
+          <a:p>
+            <a:pPr algn="ctr">
+              <a:spcAft>
+                <a:spcPts val="0"/>
+              </a:spcAft>
+              <a:defRPr sz="1600">
+                <a:solidFill>
+                  <a:srgbClr val="8B949E"/>
+                </a:solidFill>
+                <a:latin typeface="Consolas"/>
+              </a:defRPr>
+            </a:pPr>
+          </a:p>
+          <a:p>
+            <a:pPr algn="ctr">
+              <a:spcAft>
+                <a:spcPts val="0"/>
+              </a:spcAft>
+              <a:defRPr sz="1600">
+                <a:solidFill>
+                  <a:srgbClr val="58A6FF"/>
+                </a:solidFill>
+                <a:latin typeface="Consolas"/>
+              </a:defRPr>
+            </a:pPr>
+            <a:r>
+              <a:t>$ ./presentation.sh</a:t>
+            </a:r>
+          </a:p>
+          <a:p>
+            <a:pPr algn="ctr">
+              <a:spcAft>
+                <a:spcPts val="0"/>
+              </a:spcAft>
+              <a:defRPr sz="1600">
+                <a:solidFill>
+                  <a:srgbClr val="8B949E"/>
+                </a:solidFill>
+                <a:latin typeface="Consolas"/>
+              </a:defRPr>
+            </a:pPr>
+          </a:p>
+          <a:p>
+            <a:pPr algn="ctr">
+              <a:spcAft>
+                <a:spcPts val="0"/>
+              </a:spcAft>
+              <a:defRPr sz="1600">
+                <a:solidFill>
+                  <a:srgbClr val="C9D1D9"/>
+                </a:solidFill>
+                <a:latin typeface="Consolas"/>
+              </a:defRPr>
+            </a:pPr>
+            <a:r>
               <a:t>// ML-accelerated IR spectroscopy</a:t>
             </a:r>
           </a:p>
-        </p:txBody>
-      </p:sp>
-      <p:sp>
-        <p:nvSpPr>
-          <p:cNvPr id="4" name="TextBox 3"/>
+          <a:p>
+            <a:pPr algn="ctr">
+              <a:spcAft>
+                <a:spcPts val="0"/>
+              </a:spcAft>
+              <a:defRPr sz="1600">
+                <a:solidFill>
+                  <a:srgbClr val="8B949E"/>
+                </a:solidFill>
+                <a:latin typeface="Consolas"/>
+              </a:defRPr>
+            </a:pPr>
+            <a:r>
+              <a:t>// MACE × Gaussian 16 · ZMQ · VPT2</a:t>
+            </a:r>
+          </a:p>
+        </p:txBody>
+      </p:sp>
+      <p:sp>
+        <p:nvSpPr>
+          <p:cNvPr id="5" name="TextBox 4"/>
           <p:cNvSpPr txBox="1"/>
           <p:nvPr/>
         </p:nvSpPr>
@@ -3273,8 +3437,8 @@
         </p:nvSpPr>
         <p:spPr>
           <a:xfrm>
-            <a:off x="457200" y="228600"/>
-            <a:ext cx="3657600" cy="274320"/>
+            <a:off x="457200" y="201168"/>
+            <a:ext cx="7315200" cy="274320"/>
           </a:xfrm>
           <a:prstGeom prst="rect">
             <a:avLst/>
@@ -3288,7 +3452,7 @@
           <a:lstStyle/>
           <a:p>
             <a:pPr>
-              <a:defRPr sz="1100">
+              <a:defRPr sz="1000">
                 <a:solidFill>
                   <a:srgbClr val="8B949E"/>
                 </a:solidFill>
@@ -3296,7 +3460,7 @@
               </a:defRPr>
             </a:pPr>
             <a:r>
-              <a:t>style 2 — block letters</a:t>
+              <a:t>// style 2 — ASCII IR spectrum</a:t>
             </a:r>
           </a:p>
         </p:txBody>
@@ -3309,8 +3473,8 @@
         </p:nvSpPr>
         <p:spPr>
           <a:xfrm>
-            <a:off x="182880" y="1463040"/>
-            <a:ext cx="8778240" cy="1371600"/>
+            <a:off x="365760" y="731520"/>
+            <a:ext cx="8412480" cy="4023360"/>
           </a:xfrm>
           <a:prstGeom prst="rect">
             <a:avLst/>
@@ -3323,11 +3487,11 @@
           </a:bodyPr>
           <a:lstStyle/>
           <a:p>
-            <a:pPr algn="ctr">
+            <a:pPr algn="l">
               <a:spcAft>
                 <a:spcPts val="0"/>
               </a:spcAft>
-              <a:defRPr sz="1000">
+              <a:defRPr sz="1200">
                 <a:solidFill>
                   <a:srgbClr val="58A6FF"/>
                 </a:solidFill>
@@ -3335,15 +3499,15 @@
               </a:defRPr>
             </a:pPr>
             <a:r>
-              <a:t> __  __   _   ___ ___    __ _   _   _   _ ___ ___ _   _   _  _ </a:t>
-            </a:r>
-          </a:p>
-          <a:p>
-            <a:pPr algn="ctr">
+              <a:t>            |          ||                             </a:t>
+            </a:r>
+          </a:p>
+          <a:p>
+            <a:pPr algn="l">
               <a:spcAft>
                 <a:spcPts val="0"/>
               </a:spcAft>
-              <a:defRPr sz="1000">
+              <a:defRPr sz="1200">
                 <a:solidFill>
                   <a:srgbClr val="58A6FF"/>
                 </a:solidFill>
@@ -3351,15 +3515,15 @@
               </a:defRPr>
             </a:pPr>
             <a:r>
-              <a:t>|  \/  | /_\ / __| __|  / _` | /_\ | | | / __/ __| | /_\ | \| |</a:t>
-            </a:r>
-          </a:p>
-          <a:p>
-            <a:pPr algn="ctr">
+              <a:t>           |||         |||                            </a:t>
+            </a:r>
+          </a:p>
+          <a:p>
+            <a:pPr algn="l">
               <a:spcAft>
                 <a:spcPts val="0"/>
               </a:spcAft>
-              <a:defRPr sz="1000">
+              <a:defRPr sz="1200">
                 <a:solidFill>
                   <a:srgbClr val="58A6FF"/>
                 </a:solidFill>
@@ -3367,31 +3531,63 @@
               </a:defRPr>
             </a:pPr>
             <a:r>
-              <a:t>| |\/| |/ _ \ (__| _|  | (_| |/ _ \| |_| \__ \__ \ |/ _ \| .` |</a:t>
-            </a:r>
-          </a:p>
-          <a:p>
-            <a:pPr algn="ctr">
+              <a:t>           |||   |     |||             |    |         </a:t>
+            </a:r>
+          </a:p>
+          <a:p>
+            <a:pPr algn="l">
               <a:spcAft>
                 <a:spcPts val="0"/>
               </a:spcAft>
-              <a:defRPr sz="1000">
-                <a:solidFill>
-                  <a:srgbClr val="58A6FF"/>
-                </a:solidFill>
-                <a:latin typeface="Consolas"/>
-              </a:defRPr>
-            </a:pPr>
-            <a:r>
-              <a:t>|_|  |_/_/ \_\___|___|  \__, /_/ \_\\___/|___/___/_/_/ \_\_|\_|</a:t>
-            </a:r>
-          </a:p>
-          <a:p>
-            <a:pPr algn="ctr">
+              <a:defRPr sz="1200">
+                <a:solidFill>
+                  <a:srgbClr val="C9D1D9"/>
+                </a:solidFill>
+                <a:latin typeface="Consolas"/>
+              </a:defRPr>
+            </a:pPr>
+            <a:r>
+              <a:t>      ||  |||||  ||  | ||||           |||  ||         </a:t>
+            </a:r>
+          </a:p>
+          <a:p>
+            <a:pPr algn="l">
               <a:spcAft>
                 <a:spcPts val="0"/>
               </a:spcAft>
-              <a:defRPr sz="1000">
+              <a:defRPr sz="1200">
+                <a:solidFill>
+                  <a:srgbClr val="C9D1D9"/>
+                </a:solidFill>
+                <a:latin typeface="Consolas"/>
+              </a:defRPr>
+            </a:pPr>
+            <a:r>
+              <a:t>     |||| ||||| ||| |||||||         | |||  |||        </a:t>
+            </a:r>
+          </a:p>
+          <a:p>
+            <a:pPr algn="l">
+              <a:spcAft>
+                <a:spcPts val="0"/>
+              </a:spcAft>
+              <a:defRPr sz="1200">
+                <a:solidFill>
+                  <a:srgbClr val="C9D1D9"/>
+                </a:solidFill>
+                <a:latin typeface="Consolas"/>
+              </a:defRPr>
+            </a:pPr>
+            <a:r>
+              <a:t>     |||| ||||| ||| |||||||        |||||| ||||        </a:t>
+            </a:r>
+          </a:p>
+          <a:p>
+            <a:pPr algn="l">
+              <a:spcAft>
+                <a:spcPts val="0"/>
+              </a:spcAft>
+              <a:defRPr sz="1200">
                 <a:solidFill>
                   <a:srgbClr val="8B949E"/>
                 </a:solidFill>
@@ -3399,7 +3595,55 @@
               </a:defRPr>
             </a:pPr>
             <a:r>
-              <a:t>                        |___/                                    </a:t>
+              <a:t>     |||| ||||| ||| |||||||        |||||| ||||        </a:t>
+            </a:r>
+          </a:p>
+          <a:p>
+            <a:pPr algn="l">
+              <a:spcAft>
+                <a:spcPts val="0"/>
+              </a:spcAft>
+              <a:defRPr sz="1200">
+                <a:solidFill>
+                  <a:srgbClr val="8B949E"/>
+                </a:solidFill>
+                <a:latin typeface="Consolas"/>
+              </a:defRPr>
+            </a:pPr>
+            <a:r>
+              <a:t>     |||| ||||| ||| |||||||        |||||| ||||        </a:t>
+            </a:r>
+          </a:p>
+          <a:p>
+            <a:pPr algn="l">
+              <a:spcAft>
+                <a:spcPts val="0"/>
+              </a:spcAft>
+              <a:defRPr sz="1200">
+                <a:solidFill>
+                  <a:srgbClr val="8B949E"/>
+                </a:solidFill>
+                <a:latin typeface="Consolas"/>
+              </a:defRPr>
+            </a:pPr>
+            <a:r>
+              <a:t>  ────────────────────────────────────────────────────→</a:t>
+            </a:r>
+          </a:p>
+          <a:p>
+            <a:pPr algn="l">
+              <a:spcAft>
+                <a:spcPts val="0"/>
+              </a:spcAft>
+              <a:defRPr sz="1200">
+                <a:solidFill>
+                  <a:srgbClr val="8B949E"/>
+                </a:solidFill>
+                <a:latin typeface="Consolas"/>
+              </a:defRPr>
+            </a:pPr>
+            <a:r>
+              <a:t>   400    700   1200  1680       2900 3050 3300    cm⁻¹</a:t>
             </a:r>
           </a:p>
         </p:txBody>
@@ -3412,8 +3656,8 @@
         </p:nvSpPr>
         <p:spPr>
           <a:xfrm>
-            <a:off x="914400" y="3200400"/>
-            <a:ext cx="7315200" cy="1097280"/>
+            <a:off x="548640" y="5029200"/>
+            <a:ext cx="8229600" cy="914400"/>
           </a:xfrm>
           <a:prstGeom prst="rect">
             <a:avLst/>
@@ -3426,40 +3670,40 @@
           </a:bodyPr>
           <a:lstStyle/>
           <a:p>
-            <a:pPr algn="ctr">
+            <a:pPr algn="l">
               <a:spcAft>
                 <a:spcPts val="0"/>
               </a:spcAft>
-              <a:defRPr sz="1600">
-                <a:solidFill>
-                  <a:srgbClr val="8B949E"/>
-                </a:solidFill>
-                <a:latin typeface="Consolas"/>
-              </a:defRPr>
-            </a:pPr>
-          </a:p>
-          <a:p>
-            <a:pPr algn="ctr">
+              <a:defRPr sz="1400">
+                <a:solidFill>
+                  <a:srgbClr val="58A6FF"/>
+                </a:solidFill>
+                <a:latin typeface="Consolas"/>
+              </a:defRPr>
+            </a:pPr>
+            <a:r>
+              <a:t>$ mace-gaussian run aspirin.xyz  # harmonic benchmark</a:t>
+            </a:r>
+          </a:p>
+          <a:p>
+            <a:pPr algn="l">
               <a:spcAft>
                 <a:spcPts val="0"/>
               </a:spcAft>
-              <a:defRPr sz="1600">
+              <a:defRPr sz="1400">
                 <a:solidFill>
                   <a:srgbClr val="8B949E"/>
                 </a:solidFill>
                 <a:latin typeface="Consolas"/>
               </a:defRPr>
             </a:pPr>
-            <a:r>
-              <a:t>// ML-accelerated IR spectroscopy</a:t>
-            </a:r>
-          </a:p>
-          <a:p>
-            <a:pPr algn="ctr">
+          </a:p>
+          <a:p>
+            <a:pPr algn="l">
               <a:spcAft>
                 <a:spcPts val="0"/>
               </a:spcAft>
-              <a:defRPr sz="1600">
+              <a:defRPr sz="1400">
                 <a:solidFill>
                   <a:srgbClr val="8B949E"/>
                 </a:solidFill>
@@ -3467,7 +3711,7 @@
               </a:defRPr>
             </a:pPr>
             <a:r>
-              <a:t>// MACE × Gaussian · ZMQ · VPT2</a:t>
+              <a:t>  // ML-accelerated IR spectroscopy</a:t>
             </a:r>
           </a:p>
         </p:txBody>
@@ -3542,8 +3786,8 @@
         </p:nvSpPr>
         <p:spPr>
           <a:xfrm>
-            <a:off x="457200" y="228600"/>
-            <a:ext cx="3657600" cy="274320"/>
+            <a:off x="457200" y="201168"/>
+            <a:ext cx="7315200" cy="274320"/>
           </a:xfrm>
           <a:prstGeom prst="rect">
             <a:avLst/>
@@ -3557,7 +3801,7 @@
           <a:lstStyle/>
           <a:p>
             <a:pPr>
-              <a:defRPr sz="1100">
+              <a:defRPr sz="1000">
                 <a:solidFill>
                   <a:srgbClr val="8B949E"/>
                 </a:solidFill>
@@ -3565,7 +3809,7 @@
               </a:defRPr>
             </a:pPr>
             <a:r>
-              <a:t>style 3 — box frame</a:t>
+              <a:t>// style 3 — system boot sequence</a:t>
             </a:r>
           </a:p>
         </p:txBody>
@@ -3578,8 +3822,8 @@
         </p:nvSpPr>
         <p:spPr>
           <a:xfrm>
-            <a:off x="457200" y="2194560"/>
-            <a:ext cx="8229600" cy="2011680"/>
+            <a:off x="731520" y="1371600"/>
+            <a:ext cx="8046720" cy="4114800"/>
           </a:xfrm>
           <a:prstGeom prst="rect">
             <a:avLst/>
@@ -3592,123 +3836,117 @@
           </a:bodyPr>
           <a:lstStyle/>
           <a:p>
-            <a:pPr algn="ctr">
+            <a:pPr algn="l">
               <a:spcAft>
                 <a:spcPts val="0"/>
               </a:spcAft>
-              <a:defRPr sz="1400">
-                <a:solidFill>
-                  <a:srgbClr val="8B949E"/>
-                </a:solidFill>
-                <a:latin typeface="Consolas"/>
-              </a:defRPr>
-            </a:pPr>
-            <a:r>
-              <a:t>┌────────────────────────────────────────────────────┐</a:t>
-            </a:r>
-          </a:p>
-          <a:p>
-            <a:pPr algn="ctr">
+              <a:defRPr sz="1600">
+                <a:solidFill>
+                  <a:srgbClr val="58A6FF"/>
+                </a:solidFill>
+                <a:latin typeface="Consolas"/>
+              </a:defRPr>
+            </a:pPr>
+            <a:r>
+              <a:t>  Initializing mace-gaussian v1.1</a:t>
+            </a:r>
+          </a:p>
+          <a:p>
+            <a:pPr algn="l">
               <a:spcAft>
                 <a:spcPts val="0"/>
               </a:spcAft>
-              <a:defRPr sz="1400">
+              <a:defRPr sz="1600">
                 <a:solidFill>
                   <a:srgbClr val="8B949E"/>
                 </a:solidFill>
                 <a:latin typeface="Consolas"/>
               </a:defRPr>
             </a:pPr>
-            <a:r>
-              <a:t>│                                                    │</a:t>
-            </a:r>
-          </a:p>
-          <a:p>
-            <a:pPr algn="ctr">
+          </a:p>
+          <a:p>
+            <a:pPr algn="l">
               <a:spcAft>
                 <a:spcPts val="0"/>
               </a:spcAft>
-              <a:defRPr sz="1400">
-                <a:solidFill>
-                  <a:srgbClr val="58A6FF"/>
-                </a:solidFill>
-                <a:latin typeface="Consolas"/>
-              </a:defRPr>
-            </a:pPr>
-            <a:r>
-              <a:t>│                $ ./mace_gaussian.sh                │</a:t>
-            </a:r>
-          </a:p>
-          <a:p>
-            <a:pPr algn="ctr">
+              <a:defRPr sz="1600">
+                <a:solidFill>
+                  <a:srgbClr val="3FB950"/>
+                </a:solidFill>
+                <a:latin typeface="Consolas"/>
+              </a:defRPr>
+            </a:pPr>
+            <a:r>
+              <a:t>  [========================]  Loading MACE-OMOL-0        [done]</a:t>
+            </a:r>
+          </a:p>
+          <a:p>
+            <a:pPr algn="l">
               <a:spcAft>
                 <a:spcPts val="0"/>
               </a:spcAft>
-              <a:defRPr sz="1400">
-                <a:solidFill>
-                  <a:srgbClr val="8B949E"/>
-                </a:solidFill>
-                <a:latin typeface="Consolas"/>
-              </a:defRPr>
-            </a:pPr>
-            <a:r>
-              <a:t>│                                                    │</a:t>
-            </a:r>
-          </a:p>
-          <a:p>
-            <a:pPr algn="ctr">
+              <a:defRPr sz="1600">
+                <a:solidFill>
+                  <a:srgbClr val="3FB950"/>
+                </a:solidFill>
+                <a:latin typeface="Consolas"/>
+              </a:defRPr>
+            </a:pPr>
+            <a:r>
+              <a:t>  [========================]  Loading MACE4IR dipole      [done]</a:t>
+            </a:r>
+          </a:p>
+          <a:p>
+            <a:pPr algn="l">
               <a:spcAft>
                 <a:spcPts val="0"/>
               </a:spcAft>
-              <a:defRPr sz="1400">
-                <a:solidFill>
-                  <a:srgbClr val="C9D1D9"/>
-                </a:solidFill>
-                <a:latin typeface="Consolas"/>
-              </a:defRPr>
-            </a:pPr>
-            <a:r>
-              <a:t>│ mace-gaussian  //  ML-accelerated IR spectroscopy  │</a:t>
-            </a:r>
-          </a:p>
-          <a:p>
-            <a:pPr algn="ctr">
+              <a:defRPr sz="1600">
+                <a:solidFill>
+                  <a:srgbClr val="3FB950"/>
+                </a:solidFill>
+                <a:latin typeface="Consolas"/>
+              </a:defRPr>
+            </a:pPr>
+            <a:r>
+              <a:t>  [========================]  Starting ZMQ IPC server     [done]</a:t>
+            </a:r>
+          </a:p>
+          <a:p>
+            <a:pPr algn="l">
               <a:spcAft>
                 <a:spcPts val="0"/>
               </a:spcAft>
-              <a:defRPr sz="1400">
-                <a:solidFill>
-                  <a:srgbClr val="8B949E"/>
-                </a:solidFill>
-                <a:latin typeface="Consolas"/>
-              </a:defRPr>
-            </a:pPr>
-            <a:r>
-              <a:t>│  MACE × Gaussian 16 · ZMQ bridge · VPT2 pipeline   │</a:t>
-            </a:r>
-          </a:p>
-          <a:p>
-            <a:pPr algn="ctr">
+              <a:defRPr sz="1600">
+                <a:solidFill>
+                  <a:srgbClr val="3FB950"/>
+                </a:solidFill>
+                <a:latin typeface="Consolas"/>
+              </a:defRPr>
+            </a:pPr>
+            <a:r>
+              <a:t>  [========================]  Gaussian 16 bridge ready    [done]</a:t>
+            </a:r>
+          </a:p>
+          <a:p>
+            <a:pPr algn="l">
               <a:spcAft>
                 <a:spcPts val="0"/>
               </a:spcAft>
-              <a:defRPr sz="1400">
+              <a:defRPr sz="1600">
                 <a:solidFill>
                   <a:srgbClr val="8B949E"/>
                 </a:solidFill>
                 <a:latin typeface="Consolas"/>
               </a:defRPr>
             </a:pPr>
-            <a:r>
-              <a:t>│                                                    │</a:t>
-            </a:r>
-          </a:p>
-          <a:p>
-            <a:pPr algn="ctr">
+          </a:p>
+          <a:p>
+            <a:pPr algn="l">
               <a:spcAft>
                 <a:spcPts val="0"/>
               </a:spcAft>
-              <a:defRPr sz="1400">
+              <a:defRPr sz="1600">
                 <a:solidFill>
                   <a:srgbClr val="8B949E"/>
                 </a:solidFill>
@@ -3716,7 +3954,65 @@
               </a:defRPr>
             </a:pPr>
             <a:r>
-              <a:t>└────────────────────────────────────────────────────┘</a:t>
+              <a:t>  ─  ─  ─  ─  ─  ─  ─  ─  ─  ─  ─  ─  ─  ─  ─  ─  ─  ─  ─  ─  ─  ─</a:t>
+            </a:r>
+          </a:p>
+          <a:p>
+            <a:pPr algn="l">
+              <a:spcAft>
+                <a:spcPts val="0"/>
+              </a:spcAft>
+              <a:defRPr sz="1600">
+                <a:solidFill>
+                  <a:srgbClr val="8B949E"/>
+                </a:solidFill>
+                <a:latin typeface="Consolas"/>
+              </a:defRPr>
+            </a:pPr>
+          </a:p>
+          <a:p>
+            <a:pPr algn="l">
+              <a:spcAft>
+                <a:spcPts val="0"/>
+              </a:spcAft>
+              <a:defRPr sz="1600">
+                <a:solidFill>
+                  <a:srgbClr val="58A6FF"/>
+                </a:solidFill>
+                <a:latin typeface="Consolas"/>
+              </a:defRPr>
+            </a:pPr>
+            <a:r>
+              <a:t>  $ mace-gaussian run molecule.xyz</a:t>
+            </a:r>
+          </a:p>
+          <a:p>
+            <a:pPr algn="l">
+              <a:spcAft>
+                <a:spcPts val="0"/>
+              </a:spcAft>
+              <a:defRPr sz="1600">
+                <a:solidFill>
+                  <a:srgbClr val="8B949E"/>
+                </a:solidFill>
+                <a:latin typeface="Consolas"/>
+              </a:defRPr>
+            </a:pPr>
+          </a:p>
+          <a:p>
+            <a:pPr algn="l">
+              <a:spcAft>
+                <a:spcPts val="0"/>
+              </a:spcAft>
+              <a:defRPr sz="1600">
+                <a:solidFill>
+                  <a:srgbClr val="8B949E"/>
+                </a:solidFill>
+                <a:latin typeface="Consolas"/>
+              </a:defRPr>
+            </a:pPr>
+            <a:r>
+              <a:t>  // all systems go</a:t>
             </a:r>
           </a:p>
         </p:txBody>
@@ -3791,8 +4087,8 @@
         </p:nvSpPr>
         <p:spPr>
           <a:xfrm>
-            <a:off x="457200" y="228600"/>
-            <a:ext cx="3657600" cy="274320"/>
+            <a:off x="457200" y="201168"/>
+            <a:ext cx="7315200" cy="274320"/>
           </a:xfrm>
           <a:prstGeom prst="rect">
             <a:avLst/>
@@ -3806,7 +4102,7 @@
           <a:lstStyle/>
           <a:p>
             <a:pPr>
-              <a:defRPr sz="1100">
+              <a:defRPr sz="1000">
                 <a:solidFill>
                   <a:srgbClr val="8B949E"/>
                 </a:solidFill>
@@ -3814,7 +4110,7 @@
               </a:defRPr>
             </a:pPr>
             <a:r>
-              <a:t>style 4 — molecule-first</a:t>
+              <a:t>// style 4 — v1 spirit — minimal + centered</a:t>
             </a:r>
           </a:p>
         </p:txBody>
@@ -3827,8 +4123,8 @@
         </p:nvSpPr>
         <p:spPr>
           <a:xfrm>
-            <a:off x="914400" y="1463040"/>
-            <a:ext cx="7315200" cy="1280160"/>
+            <a:off x="914400" y="2377440"/>
+            <a:ext cx="7315200" cy="2011680"/>
           </a:xfrm>
           <a:prstGeom prst="rect">
             <a:avLst/>
@@ -3845,15 +4141,15 @@
               <a:spcAft>
                 <a:spcPts val="0"/>
               </a:spcAft>
-              <a:defRPr sz="1700">
-                <a:solidFill>
-                  <a:srgbClr val="3FB950"/>
-                </a:solidFill>
-                <a:latin typeface="Consolas"/>
-              </a:defRPr>
-            </a:pPr>
-            <a:r>
-              <a:t>      O          O   OH   </a:t>
+              <a:defRPr sz="3000">
+                <a:solidFill>
+                  <a:srgbClr val="58A6FF"/>
+                </a:solidFill>
+                <a:latin typeface="Consolas"/>
+              </a:defRPr>
+            </a:pPr>
+            <a:r>
+              <a:t>$ ./presentation.sh</a:t>
             </a:r>
           </a:p>
           <a:p>
@@ -3861,39 +4157,33 @@
               <a:spcAft>
                 <a:spcPts val="0"/>
               </a:spcAft>
-              <a:defRPr sz="1700">
-                <a:solidFill>
-                  <a:srgbClr val="3FB950"/>
-                </a:solidFill>
-                <a:latin typeface="Consolas"/>
-              </a:defRPr>
-            </a:pPr>
-            <a:r>
-              <a:t>     / \         ‖   |    </a:t>
-            </a:r>
+              <a:defRPr sz="3000">
+                <a:solidFill>
+                  <a:srgbClr val="8B949E"/>
+                </a:solidFill>
+                <a:latin typeface="Consolas"/>
+              </a:defRPr>
+            </a:pPr>
           </a:p>
           <a:p>
             <a:pPr algn="ctr">
               <a:spcAft>
                 <a:spcPts val="0"/>
               </a:spcAft>
-              <a:defRPr sz="1700">
-                <a:solidFill>
-                  <a:srgbClr val="3FB950"/>
-                </a:solidFill>
-                <a:latin typeface="Consolas"/>
-              </a:defRPr>
-            </a:pPr>
-            <a:r>
-              <a:t>    H   H    CH₃-C-O-C₆H₄-COOH</a:t>
-            </a:r>
+              <a:defRPr sz="3000">
+                <a:solidFill>
+                  <a:srgbClr val="8B949E"/>
+                </a:solidFill>
+                <a:latin typeface="Consolas"/>
+              </a:defRPr>
+            </a:pPr>
           </a:p>
           <a:p>
             <a:pPr algn="ctr">
               <a:spcAft>
                 <a:spcPts val="0"/>
               </a:spcAft>
-              <a:defRPr sz="1700">
+              <a:defRPr sz="3000">
                 <a:solidFill>
                   <a:srgbClr val="8B949E"/>
                 </a:solidFill>
@@ -3901,7 +4191,7 @@
               </a:defRPr>
             </a:pPr>
             <a:r>
-              <a:t>    H₂O           aspirin  </a:t>
+              <a:t>// ML-accelerated IR spectroscopy</a:t>
             </a:r>
           </a:p>
         </p:txBody>
@@ -3909,87 +4199,6 @@
       <p:sp>
         <p:nvSpPr>
           <p:cNvPr id="4" name="TextBox 3"/>
-          <p:cNvSpPr txBox="1"/>
-          <p:nvPr/>
-        </p:nvSpPr>
-        <p:spPr>
-          <a:xfrm>
-            <a:off x="914400" y="3017520"/>
-            <a:ext cx="7315200" cy="1371600"/>
-          </a:xfrm>
-          <a:prstGeom prst="rect">
-            <a:avLst/>
-          </a:prstGeom>
-          <a:noFill/>
-        </p:spPr>
-        <p:txBody>
-          <a:bodyPr wrap="none">
-            <a:spAutoFit/>
-          </a:bodyPr>
-          <a:lstStyle/>
-          <a:p>
-            <a:pPr algn="ctr">
-              <a:spcAft>
-                <a:spcPts val="0"/>
-              </a:spcAft>
-              <a:defRPr sz="2000">
-                <a:solidFill>
-                  <a:srgbClr val="8B949E"/>
-                </a:solidFill>
-                <a:latin typeface="Consolas"/>
-              </a:defRPr>
-            </a:pPr>
-          </a:p>
-          <a:p>
-            <a:pPr algn="ctr">
-              <a:spcAft>
-                <a:spcPts val="0"/>
-              </a:spcAft>
-              <a:defRPr sz="2000">
-                <a:solidFill>
-                  <a:srgbClr val="58A6FF"/>
-                </a:solidFill>
-                <a:latin typeface="Consolas"/>
-              </a:defRPr>
-            </a:pPr>
-            <a:r>
-              <a:t>$ python3 mace_gaussian.py water.xyz</a:t>
-            </a:r>
-          </a:p>
-          <a:p>
-            <a:pPr algn="ctr">
-              <a:spcAft>
-                <a:spcPts val="0"/>
-              </a:spcAft>
-              <a:defRPr sz="2000">
-                <a:solidFill>
-                  <a:srgbClr val="8B949E"/>
-                </a:solidFill>
-                <a:latin typeface="Consolas"/>
-              </a:defRPr>
-            </a:pPr>
-          </a:p>
-          <a:p>
-            <a:pPr algn="ctr">
-              <a:spcAft>
-                <a:spcPts val="0"/>
-              </a:spcAft>
-              <a:defRPr sz="2000">
-                <a:solidFill>
-                  <a:srgbClr val="8B949E"/>
-                </a:solidFill>
-                <a:latin typeface="Consolas"/>
-              </a:defRPr>
-            </a:pPr>
-            <a:r>
-              <a:t>// ML potentials + Gaussian VPT2</a:t>
-            </a:r>
-          </a:p>
-        </p:txBody>
-      </p:sp>
-      <p:sp>
-        <p:nvSpPr>
-          <p:cNvPr id="5" name="TextBox 4"/>
           <p:cNvSpPr txBox="1"/>
           <p:nvPr/>
         </p:nvSpPr>

</xml_diff>

<commit_message>
feat(banners): add lean + block fonts with filled variants (slides 5-8)
Co-Authored-By: Claude Opus 4.6 <noreply@anthropic.com>
</commit_message>
<xml_diff>
--- a/presentation/banners/title_banners.pptx
+++ b/presentation/banners/title_banners.pptx
@@ -9,6 +9,10 @@
     <p:sldId id="257" r:id="rId8"/>
     <p:sldId id="258" r:id="rId9"/>
     <p:sldId id="259" r:id="rId10"/>
+    <p:sldId id="260" r:id="rId11"/>
+    <p:sldId id="261" r:id="rId12"/>
+    <p:sldId id="262" r:id="rId13"/>
+    <p:sldId id="263" r:id="rId14"/>
   </p:sldIdLst>
   <p:sldSz cx="9144000" cy="6858000" type="screen4x3"/>
   <p:notesSz cx="6858000" cy="9144000"/>
@@ -4199,6 +4203,1262 @@
       <p:sp>
         <p:nvSpPr>
           <p:cNvPr id="4" name="TextBox 3"/>
+          <p:cNvSpPr txBox="1"/>
+          <p:nvPr/>
+        </p:nvSpPr>
+        <p:spPr>
+          <a:xfrm>
+            <a:off x="914400" y="6263640"/>
+            <a:ext cx="7315200" cy="365760"/>
+          </a:xfrm>
+          <a:prstGeom prst="rect">
+            <a:avLst/>
+          </a:prstGeom>
+          <a:noFill/>
+        </p:spPr>
+        <p:txBody>
+          <a:bodyPr wrap="none">
+            <a:spAutoFit/>
+          </a:bodyPr>
+          <a:lstStyle/>
+          <a:p>
+            <a:pPr algn="ctr">
+              <a:defRPr sz="1100">
+                <a:solidFill>
+                  <a:srgbClr val="8B949E"/>
+                </a:solidFill>
+                <a:latin typeface="Consolas"/>
+              </a:defRPr>
+            </a:pPr>
+            <a:r>
+              <a:t>Manuel Ott · Hofer Lab · 2026-03-26</a:t>
+            </a:r>
+          </a:p>
+        </p:txBody>
+      </p:sp>
+    </p:spTree>
+  </p:cSld>
+  <p:clrMapOvr>
+    <a:masterClrMapping/>
+  </p:clrMapOvr>
+</p:sld>
+</file>
+
+<file path=ppt/slides/slide5.xml><?xml version="1.0" encoding="utf-8"?>
+<p:sld xmlns:a="http://schemas.openxmlformats.org/drawingml/2006/main" xmlns:p="http://schemas.openxmlformats.org/presentationml/2006/main" xmlns:r="http://schemas.openxmlformats.org/officeDocument/2006/relationships">
+  <p:cSld>
+    <p:bg>
+      <p:bgPr>
+        <a:solidFill>
+          <a:srgbClr val="0D1117"/>
+        </a:solidFill>
+        <a:effectLst/>
+      </p:bgPr>
+    </p:bg>
+    <p:spTree>
+      <p:nvGrpSpPr>
+        <p:cNvPr id="1" name=""/>
+        <p:cNvGrpSpPr/>
+        <p:nvPr/>
+      </p:nvGrpSpPr>
+      <p:grpSpPr/>
+      <p:sp>
+        <p:nvSpPr>
+          <p:cNvPr id="2" name="TextBox 1"/>
+          <p:cNvSpPr txBox="1"/>
+          <p:nvPr/>
+        </p:nvSpPr>
+        <p:spPr>
+          <a:xfrm>
+            <a:off x="457200" y="201168"/>
+            <a:ext cx="7315200" cy="274320"/>
+          </a:xfrm>
+          <a:prstGeom prst="rect">
+            <a:avLst/>
+          </a:prstGeom>
+          <a:noFill/>
+        </p:spPr>
+        <p:txBody>
+          <a:bodyPr wrap="none">
+            <a:spAutoFit/>
+          </a:bodyPr>
+          <a:lstStyle/>
+          <a:p>
+            <a:pPr>
+              <a:defRPr sz="1000">
+                <a:solidFill>
+                  <a:srgbClr val="8B949E"/>
+                </a:solidFill>
+                <a:latin typeface="Consolas"/>
+              </a:defRPr>
+            </a:pPr>
+            <a:r>
+              <a:t>// style 5 — lean — thin strokes</a:t>
+            </a:r>
+          </a:p>
+        </p:txBody>
+      </p:sp>
+      <p:sp>
+        <p:nvSpPr>
+          <p:cNvPr id="3" name="TextBox 2"/>
+          <p:cNvSpPr txBox="1"/>
+          <p:nvPr/>
+        </p:nvSpPr>
+        <p:spPr>
+          <a:xfrm>
+            <a:off x="365760" y="914400"/>
+            <a:ext cx="8412480" cy="2560320"/>
+          </a:xfrm>
+          <a:prstGeom prst="rect">
+            <a:avLst/>
+          </a:prstGeom>
+          <a:noFill/>
+        </p:spPr>
+        <p:txBody>
+          <a:bodyPr wrap="none">
+            <a:spAutoFit/>
+          </a:bodyPr>
+          <a:lstStyle/>
+          <a:p>
+            <a:pPr algn="ctr">
+              <a:spcAft>
+                <a:spcPts val="0"/>
+              </a:spcAft>
+              <a:defRPr sz="1600">
+                <a:solidFill>
+                  <a:srgbClr val="58A6FF"/>
+                </a:solidFill>
+                <a:latin typeface="Consolas"/>
+              </a:defRPr>
+            </a:pPr>
+            <a:r>
+              <a:t>    _/      _/    _/_/      _/_/_/  _/_/_/_/   </a:t>
+            </a:r>
+          </a:p>
+          <a:p>
+            <a:pPr algn="ctr">
+              <a:spcAft>
+                <a:spcPts val="0"/>
+              </a:spcAft>
+              <a:defRPr sz="1600">
+                <a:solidFill>
+                  <a:srgbClr val="58A6FF"/>
+                </a:solidFill>
+                <a:latin typeface="Consolas"/>
+              </a:defRPr>
+            </a:pPr>
+            <a:r>
+              <a:t>   _/_/  _/_/  _/    _/  _/        _/          </a:t>
+            </a:r>
+          </a:p>
+          <a:p>
+            <a:pPr algn="ctr">
+              <a:spcAft>
+                <a:spcPts val="0"/>
+              </a:spcAft>
+              <a:defRPr sz="1600">
+                <a:solidFill>
+                  <a:srgbClr val="58A6FF"/>
+                </a:solidFill>
+                <a:latin typeface="Consolas"/>
+              </a:defRPr>
+            </a:pPr>
+            <a:r>
+              <a:t>  _/  _/  _/  _/_/_/_/  _/        _/_/_/       </a:t>
+            </a:r>
+          </a:p>
+          <a:p>
+            <a:pPr algn="ctr">
+              <a:spcAft>
+                <a:spcPts val="0"/>
+              </a:spcAft>
+              <a:defRPr sz="1600">
+                <a:solidFill>
+                  <a:srgbClr val="58A6FF"/>
+                </a:solidFill>
+                <a:latin typeface="Consolas"/>
+              </a:defRPr>
+            </a:pPr>
+            <a:r>
+              <a:t> _/      _/  _/    _/  _/        _/            </a:t>
+            </a:r>
+          </a:p>
+          <a:p>
+            <a:pPr algn="ctr">
+              <a:spcAft>
+                <a:spcPts val="0"/>
+              </a:spcAft>
+              <a:defRPr sz="1600">
+                <a:solidFill>
+                  <a:srgbClr val="58A6FF"/>
+                </a:solidFill>
+                <a:latin typeface="Consolas"/>
+              </a:defRPr>
+            </a:pPr>
+            <a:r>
+              <a:t>_/      _/  _/    _/    _/_/_/  _/_/_/_/       </a:t>
+            </a:r>
+          </a:p>
+        </p:txBody>
+      </p:sp>
+      <p:sp>
+        <p:nvSpPr>
+          <p:cNvPr id="4" name="TextBox 3"/>
+          <p:cNvSpPr txBox="1"/>
+          <p:nvPr/>
+        </p:nvSpPr>
+        <p:spPr>
+          <a:xfrm>
+            <a:off x="731520" y="3749039"/>
+            <a:ext cx="7680960" cy="1828800"/>
+          </a:xfrm>
+          <a:prstGeom prst="rect">
+            <a:avLst/>
+          </a:prstGeom>
+          <a:noFill/>
+        </p:spPr>
+        <p:txBody>
+          <a:bodyPr wrap="none">
+            <a:spAutoFit/>
+          </a:bodyPr>
+          <a:lstStyle/>
+          <a:p>
+            <a:pPr algn="ctr">
+              <a:spcAft>
+                <a:spcPts val="0"/>
+              </a:spcAft>
+              <a:defRPr sz="1600">
+                <a:solidFill>
+                  <a:srgbClr val="8B949E"/>
+                </a:solidFill>
+                <a:latin typeface="Consolas"/>
+              </a:defRPr>
+            </a:pPr>
+            <a:r>
+              <a:t>────────────────────────────────────────────</a:t>
+            </a:r>
+          </a:p>
+          <a:p>
+            <a:pPr algn="ctr">
+              <a:spcAft>
+                <a:spcPts val="0"/>
+              </a:spcAft>
+              <a:defRPr sz="1600">
+                <a:solidFill>
+                  <a:srgbClr val="8B949E"/>
+                </a:solidFill>
+                <a:latin typeface="Consolas"/>
+              </a:defRPr>
+            </a:pPr>
+          </a:p>
+          <a:p>
+            <a:pPr algn="ctr">
+              <a:spcAft>
+                <a:spcPts val="0"/>
+              </a:spcAft>
+              <a:defRPr sz="1600">
+                <a:solidFill>
+                  <a:srgbClr val="58A6FF"/>
+                </a:solidFill>
+                <a:latin typeface="Consolas"/>
+              </a:defRPr>
+            </a:pPr>
+            <a:r>
+              <a:t>$ mace-gaussian run molecule.xyz</a:t>
+            </a:r>
+          </a:p>
+          <a:p>
+            <a:pPr algn="ctr">
+              <a:spcAft>
+                <a:spcPts val="0"/>
+              </a:spcAft>
+              <a:defRPr sz="1600">
+                <a:solidFill>
+                  <a:srgbClr val="8B949E"/>
+                </a:solidFill>
+                <a:latin typeface="Consolas"/>
+              </a:defRPr>
+            </a:pPr>
+          </a:p>
+          <a:p>
+            <a:pPr algn="ctr">
+              <a:spcAft>
+                <a:spcPts val="0"/>
+              </a:spcAft>
+              <a:defRPr sz="1600">
+                <a:solidFill>
+                  <a:srgbClr val="C9D1D9"/>
+                </a:solidFill>
+                <a:latin typeface="Consolas"/>
+              </a:defRPr>
+            </a:pPr>
+            <a:r>
+              <a:t>// ML-accelerated IR spectroscopy</a:t>
+            </a:r>
+          </a:p>
+          <a:p>
+            <a:pPr algn="ctr">
+              <a:spcAft>
+                <a:spcPts val="0"/>
+              </a:spcAft>
+              <a:defRPr sz="1600">
+                <a:solidFill>
+                  <a:srgbClr val="8B949E"/>
+                </a:solidFill>
+                <a:latin typeface="Consolas"/>
+              </a:defRPr>
+            </a:pPr>
+            <a:r>
+              <a:t>// MACE × Gaussian 16 · ZMQ · VPT2</a:t>
+            </a:r>
+          </a:p>
+        </p:txBody>
+      </p:sp>
+      <p:sp>
+        <p:nvSpPr>
+          <p:cNvPr id="5" name="TextBox 4"/>
+          <p:cNvSpPr txBox="1"/>
+          <p:nvPr/>
+        </p:nvSpPr>
+        <p:spPr>
+          <a:xfrm>
+            <a:off x="914400" y="6263640"/>
+            <a:ext cx="7315200" cy="365760"/>
+          </a:xfrm>
+          <a:prstGeom prst="rect">
+            <a:avLst/>
+          </a:prstGeom>
+          <a:noFill/>
+        </p:spPr>
+        <p:txBody>
+          <a:bodyPr wrap="none">
+            <a:spAutoFit/>
+          </a:bodyPr>
+          <a:lstStyle/>
+          <a:p>
+            <a:pPr algn="ctr">
+              <a:defRPr sz="1100">
+                <a:solidFill>
+                  <a:srgbClr val="8B949E"/>
+                </a:solidFill>
+                <a:latin typeface="Consolas"/>
+              </a:defRPr>
+            </a:pPr>
+            <a:r>
+              <a:t>Manuel Ott · Hofer Lab · 2026-03-26</a:t>
+            </a:r>
+          </a:p>
+        </p:txBody>
+      </p:sp>
+    </p:spTree>
+  </p:cSld>
+  <p:clrMapOvr>
+    <a:masterClrMapping/>
+  </p:clrMapOvr>
+</p:sld>
+</file>
+
+<file path=ppt/slides/slide6.xml><?xml version="1.0" encoding="utf-8"?>
+<p:sld xmlns:a="http://schemas.openxmlformats.org/drawingml/2006/main" xmlns:p="http://schemas.openxmlformats.org/presentationml/2006/main" xmlns:r="http://schemas.openxmlformats.org/officeDocument/2006/relationships">
+  <p:cSld>
+    <p:bg>
+      <p:bgPr>
+        <a:solidFill>
+          <a:srgbClr val="0D1117"/>
+        </a:solidFill>
+        <a:effectLst/>
+      </p:bgPr>
+    </p:bg>
+    <p:spTree>
+      <p:nvGrpSpPr>
+        <p:cNvPr id="1" name=""/>
+        <p:cNvGrpSpPr/>
+        <p:nvPr/>
+      </p:nvGrpSpPr>
+      <p:grpSpPr/>
+      <p:sp>
+        <p:nvSpPr>
+          <p:cNvPr id="2" name="TextBox 1"/>
+          <p:cNvSpPr txBox="1"/>
+          <p:nvPr/>
+        </p:nvSpPr>
+        <p:spPr>
+          <a:xfrm>
+            <a:off x="457200" y="201168"/>
+            <a:ext cx="7315200" cy="274320"/>
+          </a:xfrm>
+          <a:prstGeom prst="rect">
+            <a:avLst/>
+          </a:prstGeom>
+          <a:noFill/>
+        </p:spPr>
+        <p:txBody>
+          <a:bodyPr wrap="none">
+            <a:spAutoFit/>
+          </a:bodyPr>
+          <a:lstStyle/>
+          <a:p>
+            <a:pPr>
+              <a:defRPr sz="1000">
+                <a:solidFill>
+                  <a:srgbClr val="8B949E"/>
+                </a:solidFill>
+                <a:latin typeface="Consolas"/>
+              </a:defRPr>
+            </a:pPr>
+            <a:r>
+              <a:t>// style 6 — lean — filled █</a:t>
+            </a:r>
+          </a:p>
+        </p:txBody>
+      </p:sp>
+      <p:sp>
+        <p:nvSpPr>
+          <p:cNvPr id="3" name="TextBox 2"/>
+          <p:cNvSpPr txBox="1"/>
+          <p:nvPr/>
+        </p:nvSpPr>
+        <p:spPr>
+          <a:xfrm>
+            <a:off x="365760" y="914400"/>
+            <a:ext cx="8412480" cy="2560320"/>
+          </a:xfrm>
+          <a:prstGeom prst="rect">
+            <a:avLst/>
+          </a:prstGeom>
+          <a:noFill/>
+        </p:spPr>
+        <p:txBody>
+          <a:bodyPr wrap="none">
+            <a:spAutoFit/>
+          </a:bodyPr>
+          <a:lstStyle/>
+          <a:p>
+            <a:pPr algn="ctr">
+              <a:spcAft>
+                <a:spcPts val="0"/>
+              </a:spcAft>
+              <a:defRPr sz="1600">
+                <a:solidFill>
+                  <a:srgbClr val="58A6FF"/>
+                </a:solidFill>
+                <a:latin typeface="Consolas"/>
+              </a:defRPr>
+            </a:pPr>
+            <a:r>
+              <a:t>    ██      ██    ████      ██████  ████████   </a:t>
+            </a:r>
+          </a:p>
+          <a:p>
+            <a:pPr algn="ctr">
+              <a:spcAft>
+                <a:spcPts val="0"/>
+              </a:spcAft>
+              <a:defRPr sz="1600">
+                <a:solidFill>
+                  <a:srgbClr val="58A6FF"/>
+                </a:solidFill>
+                <a:latin typeface="Consolas"/>
+              </a:defRPr>
+            </a:pPr>
+            <a:r>
+              <a:t>   ████  ████  ██    ██  ██        ██          </a:t>
+            </a:r>
+          </a:p>
+          <a:p>
+            <a:pPr algn="ctr">
+              <a:spcAft>
+                <a:spcPts val="0"/>
+              </a:spcAft>
+              <a:defRPr sz="1600">
+                <a:solidFill>
+                  <a:srgbClr val="58A6FF"/>
+                </a:solidFill>
+                <a:latin typeface="Consolas"/>
+              </a:defRPr>
+            </a:pPr>
+            <a:r>
+              <a:t>  ██  ██  ██  ████████  ██        ██████       </a:t>
+            </a:r>
+          </a:p>
+          <a:p>
+            <a:pPr algn="ctr">
+              <a:spcAft>
+                <a:spcPts val="0"/>
+              </a:spcAft>
+              <a:defRPr sz="1600">
+                <a:solidFill>
+                  <a:srgbClr val="58A6FF"/>
+                </a:solidFill>
+                <a:latin typeface="Consolas"/>
+              </a:defRPr>
+            </a:pPr>
+            <a:r>
+              <a:t> ██      ██  ██    ██  ██        ██            </a:t>
+            </a:r>
+          </a:p>
+          <a:p>
+            <a:pPr algn="ctr">
+              <a:spcAft>
+                <a:spcPts val="0"/>
+              </a:spcAft>
+              <a:defRPr sz="1600">
+                <a:solidFill>
+                  <a:srgbClr val="58A6FF"/>
+                </a:solidFill>
+                <a:latin typeface="Consolas"/>
+              </a:defRPr>
+            </a:pPr>
+            <a:r>
+              <a:t>██      ██  ██    ██    ██████  ████████       </a:t>
+            </a:r>
+          </a:p>
+        </p:txBody>
+      </p:sp>
+      <p:sp>
+        <p:nvSpPr>
+          <p:cNvPr id="4" name="TextBox 3"/>
+          <p:cNvSpPr txBox="1"/>
+          <p:nvPr/>
+        </p:nvSpPr>
+        <p:spPr>
+          <a:xfrm>
+            <a:off x="731520" y="3749039"/>
+            <a:ext cx="7680960" cy="1828800"/>
+          </a:xfrm>
+          <a:prstGeom prst="rect">
+            <a:avLst/>
+          </a:prstGeom>
+          <a:noFill/>
+        </p:spPr>
+        <p:txBody>
+          <a:bodyPr wrap="none">
+            <a:spAutoFit/>
+          </a:bodyPr>
+          <a:lstStyle/>
+          <a:p>
+            <a:pPr algn="ctr">
+              <a:spcAft>
+                <a:spcPts val="0"/>
+              </a:spcAft>
+              <a:defRPr sz="1600">
+                <a:solidFill>
+                  <a:srgbClr val="8B949E"/>
+                </a:solidFill>
+                <a:latin typeface="Consolas"/>
+              </a:defRPr>
+            </a:pPr>
+            <a:r>
+              <a:t>────────────────────────────────────────────</a:t>
+            </a:r>
+          </a:p>
+          <a:p>
+            <a:pPr algn="ctr">
+              <a:spcAft>
+                <a:spcPts val="0"/>
+              </a:spcAft>
+              <a:defRPr sz="1600">
+                <a:solidFill>
+                  <a:srgbClr val="8B949E"/>
+                </a:solidFill>
+                <a:latin typeface="Consolas"/>
+              </a:defRPr>
+            </a:pPr>
+          </a:p>
+          <a:p>
+            <a:pPr algn="ctr">
+              <a:spcAft>
+                <a:spcPts val="0"/>
+              </a:spcAft>
+              <a:defRPr sz="1600">
+                <a:solidFill>
+                  <a:srgbClr val="58A6FF"/>
+                </a:solidFill>
+                <a:latin typeface="Consolas"/>
+              </a:defRPr>
+            </a:pPr>
+            <a:r>
+              <a:t>$ mace-gaussian run molecule.xyz</a:t>
+            </a:r>
+          </a:p>
+          <a:p>
+            <a:pPr algn="ctr">
+              <a:spcAft>
+                <a:spcPts val="0"/>
+              </a:spcAft>
+              <a:defRPr sz="1600">
+                <a:solidFill>
+                  <a:srgbClr val="8B949E"/>
+                </a:solidFill>
+                <a:latin typeface="Consolas"/>
+              </a:defRPr>
+            </a:pPr>
+          </a:p>
+          <a:p>
+            <a:pPr algn="ctr">
+              <a:spcAft>
+                <a:spcPts val="0"/>
+              </a:spcAft>
+              <a:defRPr sz="1600">
+                <a:solidFill>
+                  <a:srgbClr val="C9D1D9"/>
+                </a:solidFill>
+                <a:latin typeface="Consolas"/>
+              </a:defRPr>
+            </a:pPr>
+            <a:r>
+              <a:t>// ML-accelerated IR spectroscopy</a:t>
+            </a:r>
+          </a:p>
+          <a:p>
+            <a:pPr algn="ctr">
+              <a:spcAft>
+                <a:spcPts val="0"/>
+              </a:spcAft>
+              <a:defRPr sz="1600">
+                <a:solidFill>
+                  <a:srgbClr val="8B949E"/>
+                </a:solidFill>
+                <a:latin typeface="Consolas"/>
+              </a:defRPr>
+            </a:pPr>
+            <a:r>
+              <a:t>// MACE × Gaussian 16 · ZMQ · VPT2</a:t>
+            </a:r>
+          </a:p>
+        </p:txBody>
+      </p:sp>
+      <p:sp>
+        <p:nvSpPr>
+          <p:cNvPr id="5" name="TextBox 4"/>
+          <p:cNvSpPr txBox="1"/>
+          <p:nvPr/>
+        </p:nvSpPr>
+        <p:spPr>
+          <a:xfrm>
+            <a:off x="914400" y="6263640"/>
+            <a:ext cx="7315200" cy="365760"/>
+          </a:xfrm>
+          <a:prstGeom prst="rect">
+            <a:avLst/>
+          </a:prstGeom>
+          <a:noFill/>
+        </p:spPr>
+        <p:txBody>
+          <a:bodyPr wrap="none">
+            <a:spAutoFit/>
+          </a:bodyPr>
+          <a:lstStyle/>
+          <a:p>
+            <a:pPr algn="ctr">
+              <a:defRPr sz="1100">
+                <a:solidFill>
+                  <a:srgbClr val="8B949E"/>
+                </a:solidFill>
+                <a:latin typeface="Consolas"/>
+              </a:defRPr>
+            </a:pPr>
+            <a:r>
+              <a:t>Manuel Ott · Hofer Lab · 2026-03-26</a:t>
+            </a:r>
+          </a:p>
+        </p:txBody>
+      </p:sp>
+    </p:spTree>
+  </p:cSld>
+  <p:clrMapOvr>
+    <a:masterClrMapping/>
+  </p:clrMapOvr>
+</p:sld>
+</file>
+
+<file path=ppt/slides/slide7.xml><?xml version="1.0" encoding="utf-8"?>
+<p:sld xmlns:a="http://schemas.openxmlformats.org/drawingml/2006/main" xmlns:p="http://schemas.openxmlformats.org/presentationml/2006/main" xmlns:r="http://schemas.openxmlformats.org/officeDocument/2006/relationships">
+  <p:cSld>
+    <p:bg>
+      <p:bgPr>
+        <a:solidFill>
+          <a:srgbClr val="0D1117"/>
+        </a:solidFill>
+        <a:effectLst/>
+      </p:bgPr>
+    </p:bg>
+    <p:spTree>
+      <p:nvGrpSpPr>
+        <p:cNvPr id="1" name=""/>
+        <p:cNvGrpSpPr/>
+        <p:nvPr/>
+      </p:nvGrpSpPr>
+      <p:grpSpPr/>
+      <p:sp>
+        <p:nvSpPr>
+          <p:cNvPr id="2" name="TextBox 1"/>
+          <p:cNvSpPr txBox="1"/>
+          <p:nvPr/>
+        </p:nvSpPr>
+        <p:spPr>
+          <a:xfrm>
+            <a:off x="457200" y="201168"/>
+            <a:ext cx="7315200" cy="274320"/>
+          </a:xfrm>
+          <a:prstGeom prst="rect">
+            <a:avLst/>
+          </a:prstGeom>
+          <a:noFill/>
+        </p:spPr>
+        <p:txBody>
+          <a:bodyPr wrap="none">
+            <a:spAutoFit/>
+          </a:bodyPr>
+          <a:lstStyle/>
+          <a:p>
+            <a:pPr>
+              <a:defRPr sz="1000">
+                <a:solidFill>
+                  <a:srgbClr val="8B949E"/>
+                </a:solidFill>
+                <a:latin typeface="Consolas"/>
+              </a:defRPr>
+            </a:pPr>
+            <a:r>
+              <a:t>// style 7 — block — thin strokes</a:t>
+            </a:r>
+          </a:p>
+        </p:txBody>
+      </p:sp>
+      <p:sp>
+        <p:nvSpPr>
+          <p:cNvPr id="3" name="TextBox 2"/>
+          <p:cNvSpPr txBox="1"/>
+          <p:nvPr/>
+        </p:nvSpPr>
+        <p:spPr>
+          <a:xfrm>
+            <a:off x="548640" y="914400"/>
+            <a:ext cx="8412480" cy="2560320"/>
+          </a:xfrm>
+          <a:prstGeom prst="rect">
+            <a:avLst/>
+          </a:prstGeom>
+          <a:noFill/>
+        </p:spPr>
+        <p:txBody>
+          <a:bodyPr wrap="none">
+            <a:spAutoFit/>
+          </a:bodyPr>
+          <a:lstStyle/>
+          <a:p>
+            <a:pPr algn="ctr">
+              <a:spcAft>
+                <a:spcPts val="0"/>
+              </a:spcAft>
+              <a:defRPr sz="1600">
+                <a:solidFill>
+                  <a:srgbClr val="58A6FF"/>
+                </a:solidFill>
+                <a:latin typeface="Consolas"/>
+              </a:defRPr>
+            </a:pPr>
+            <a:r>
+              <a:t>_|      _|    _|_|      _|_|_|  _|_|_|_|  </a:t>
+            </a:r>
+          </a:p>
+          <a:p>
+            <a:pPr algn="ctr">
+              <a:spcAft>
+                <a:spcPts val="0"/>
+              </a:spcAft>
+              <a:defRPr sz="1600">
+                <a:solidFill>
+                  <a:srgbClr val="58A6FF"/>
+                </a:solidFill>
+                <a:latin typeface="Consolas"/>
+              </a:defRPr>
+            </a:pPr>
+            <a:r>
+              <a:t>_|_|  _|_|  _|    _|  _|        _|        </a:t>
+            </a:r>
+          </a:p>
+          <a:p>
+            <a:pPr algn="ctr">
+              <a:spcAft>
+                <a:spcPts val="0"/>
+              </a:spcAft>
+              <a:defRPr sz="1600">
+                <a:solidFill>
+                  <a:srgbClr val="58A6FF"/>
+                </a:solidFill>
+                <a:latin typeface="Consolas"/>
+              </a:defRPr>
+            </a:pPr>
+            <a:r>
+              <a:t>_|  _|  _|  _|_|_|_|  _|        _|_|_|    </a:t>
+            </a:r>
+          </a:p>
+          <a:p>
+            <a:pPr algn="ctr">
+              <a:spcAft>
+                <a:spcPts val="0"/>
+              </a:spcAft>
+              <a:defRPr sz="1600">
+                <a:solidFill>
+                  <a:srgbClr val="58A6FF"/>
+                </a:solidFill>
+                <a:latin typeface="Consolas"/>
+              </a:defRPr>
+            </a:pPr>
+            <a:r>
+              <a:t>_|      _|  _|    _|  _|        _|        </a:t>
+            </a:r>
+          </a:p>
+          <a:p>
+            <a:pPr algn="ctr">
+              <a:spcAft>
+                <a:spcPts val="0"/>
+              </a:spcAft>
+              <a:defRPr sz="1600">
+                <a:solidFill>
+                  <a:srgbClr val="58A6FF"/>
+                </a:solidFill>
+                <a:latin typeface="Consolas"/>
+              </a:defRPr>
+            </a:pPr>
+            <a:r>
+              <a:t>_|      _|  _|    _|    _|_|_|  _|_|_|_|  </a:t>
+            </a:r>
+          </a:p>
+        </p:txBody>
+      </p:sp>
+      <p:sp>
+        <p:nvSpPr>
+          <p:cNvPr id="4" name="TextBox 3"/>
+          <p:cNvSpPr txBox="1"/>
+          <p:nvPr/>
+        </p:nvSpPr>
+        <p:spPr>
+          <a:xfrm>
+            <a:off x="731520" y="3749039"/>
+            <a:ext cx="7680960" cy="1828800"/>
+          </a:xfrm>
+          <a:prstGeom prst="rect">
+            <a:avLst/>
+          </a:prstGeom>
+          <a:noFill/>
+        </p:spPr>
+        <p:txBody>
+          <a:bodyPr wrap="none">
+            <a:spAutoFit/>
+          </a:bodyPr>
+          <a:lstStyle/>
+          <a:p>
+            <a:pPr algn="ctr">
+              <a:spcAft>
+                <a:spcPts val="0"/>
+              </a:spcAft>
+              <a:defRPr sz="1600">
+                <a:solidFill>
+                  <a:srgbClr val="8B949E"/>
+                </a:solidFill>
+                <a:latin typeface="Consolas"/>
+              </a:defRPr>
+            </a:pPr>
+            <a:r>
+              <a:t>────────────────────────────────────────────</a:t>
+            </a:r>
+          </a:p>
+          <a:p>
+            <a:pPr algn="ctr">
+              <a:spcAft>
+                <a:spcPts val="0"/>
+              </a:spcAft>
+              <a:defRPr sz="1600">
+                <a:solidFill>
+                  <a:srgbClr val="8B949E"/>
+                </a:solidFill>
+                <a:latin typeface="Consolas"/>
+              </a:defRPr>
+            </a:pPr>
+          </a:p>
+          <a:p>
+            <a:pPr algn="ctr">
+              <a:spcAft>
+                <a:spcPts val="0"/>
+              </a:spcAft>
+              <a:defRPr sz="1600">
+                <a:solidFill>
+                  <a:srgbClr val="58A6FF"/>
+                </a:solidFill>
+                <a:latin typeface="Consolas"/>
+              </a:defRPr>
+            </a:pPr>
+            <a:r>
+              <a:t>$ mace-gaussian run molecule.xyz</a:t>
+            </a:r>
+          </a:p>
+          <a:p>
+            <a:pPr algn="ctr">
+              <a:spcAft>
+                <a:spcPts val="0"/>
+              </a:spcAft>
+              <a:defRPr sz="1600">
+                <a:solidFill>
+                  <a:srgbClr val="8B949E"/>
+                </a:solidFill>
+                <a:latin typeface="Consolas"/>
+              </a:defRPr>
+            </a:pPr>
+          </a:p>
+          <a:p>
+            <a:pPr algn="ctr">
+              <a:spcAft>
+                <a:spcPts val="0"/>
+              </a:spcAft>
+              <a:defRPr sz="1600">
+                <a:solidFill>
+                  <a:srgbClr val="C9D1D9"/>
+                </a:solidFill>
+                <a:latin typeface="Consolas"/>
+              </a:defRPr>
+            </a:pPr>
+            <a:r>
+              <a:t>// ML-accelerated IR spectroscopy</a:t>
+            </a:r>
+          </a:p>
+          <a:p>
+            <a:pPr algn="ctr">
+              <a:spcAft>
+                <a:spcPts val="0"/>
+              </a:spcAft>
+              <a:defRPr sz="1600">
+                <a:solidFill>
+                  <a:srgbClr val="8B949E"/>
+                </a:solidFill>
+                <a:latin typeface="Consolas"/>
+              </a:defRPr>
+            </a:pPr>
+            <a:r>
+              <a:t>// MACE × Gaussian 16 · ZMQ · VPT2</a:t>
+            </a:r>
+          </a:p>
+        </p:txBody>
+      </p:sp>
+      <p:sp>
+        <p:nvSpPr>
+          <p:cNvPr id="5" name="TextBox 4"/>
+          <p:cNvSpPr txBox="1"/>
+          <p:nvPr/>
+        </p:nvSpPr>
+        <p:spPr>
+          <a:xfrm>
+            <a:off x="914400" y="6263640"/>
+            <a:ext cx="7315200" cy="365760"/>
+          </a:xfrm>
+          <a:prstGeom prst="rect">
+            <a:avLst/>
+          </a:prstGeom>
+          <a:noFill/>
+        </p:spPr>
+        <p:txBody>
+          <a:bodyPr wrap="none">
+            <a:spAutoFit/>
+          </a:bodyPr>
+          <a:lstStyle/>
+          <a:p>
+            <a:pPr algn="ctr">
+              <a:defRPr sz="1100">
+                <a:solidFill>
+                  <a:srgbClr val="8B949E"/>
+                </a:solidFill>
+                <a:latin typeface="Consolas"/>
+              </a:defRPr>
+            </a:pPr>
+            <a:r>
+              <a:t>Manuel Ott · Hofer Lab · 2026-03-26</a:t>
+            </a:r>
+          </a:p>
+        </p:txBody>
+      </p:sp>
+    </p:spTree>
+  </p:cSld>
+  <p:clrMapOvr>
+    <a:masterClrMapping/>
+  </p:clrMapOvr>
+</p:sld>
+</file>
+
+<file path=ppt/slides/slide8.xml><?xml version="1.0" encoding="utf-8"?>
+<p:sld xmlns:a="http://schemas.openxmlformats.org/drawingml/2006/main" xmlns:p="http://schemas.openxmlformats.org/presentationml/2006/main" xmlns:r="http://schemas.openxmlformats.org/officeDocument/2006/relationships">
+  <p:cSld>
+    <p:bg>
+      <p:bgPr>
+        <a:solidFill>
+          <a:srgbClr val="0D1117"/>
+        </a:solidFill>
+        <a:effectLst/>
+      </p:bgPr>
+    </p:bg>
+    <p:spTree>
+      <p:nvGrpSpPr>
+        <p:cNvPr id="1" name=""/>
+        <p:cNvGrpSpPr/>
+        <p:nvPr/>
+      </p:nvGrpSpPr>
+      <p:grpSpPr/>
+      <p:sp>
+        <p:nvSpPr>
+          <p:cNvPr id="2" name="TextBox 1"/>
+          <p:cNvSpPr txBox="1"/>
+          <p:nvPr/>
+        </p:nvSpPr>
+        <p:spPr>
+          <a:xfrm>
+            <a:off x="457200" y="201168"/>
+            <a:ext cx="7315200" cy="274320"/>
+          </a:xfrm>
+          <a:prstGeom prst="rect">
+            <a:avLst/>
+          </a:prstGeom>
+          <a:noFill/>
+        </p:spPr>
+        <p:txBody>
+          <a:bodyPr wrap="none">
+            <a:spAutoFit/>
+          </a:bodyPr>
+          <a:lstStyle/>
+          <a:p>
+            <a:pPr>
+              <a:defRPr sz="1000">
+                <a:solidFill>
+                  <a:srgbClr val="8B949E"/>
+                </a:solidFill>
+                <a:latin typeface="Consolas"/>
+              </a:defRPr>
+            </a:pPr>
+            <a:r>
+              <a:t>// style 8 — block — filled █</a:t>
+            </a:r>
+          </a:p>
+        </p:txBody>
+      </p:sp>
+      <p:sp>
+        <p:nvSpPr>
+          <p:cNvPr id="3" name="TextBox 2"/>
+          <p:cNvSpPr txBox="1"/>
+          <p:nvPr/>
+        </p:nvSpPr>
+        <p:spPr>
+          <a:xfrm>
+            <a:off x="548640" y="914400"/>
+            <a:ext cx="8412480" cy="2560320"/>
+          </a:xfrm>
+          <a:prstGeom prst="rect">
+            <a:avLst/>
+          </a:prstGeom>
+          <a:noFill/>
+        </p:spPr>
+        <p:txBody>
+          <a:bodyPr wrap="none">
+            <a:spAutoFit/>
+          </a:bodyPr>
+          <a:lstStyle/>
+          <a:p>
+            <a:pPr algn="ctr">
+              <a:spcAft>
+                <a:spcPts val="0"/>
+              </a:spcAft>
+              <a:defRPr sz="1600">
+                <a:solidFill>
+                  <a:srgbClr val="58A6FF"/>
+                </a:solidFill>
+                <a:latin typeface="Consolas"/>
+              </a:defRPr>
+            </a:pPr>
+            <a:r>
+              <a:t>██      ██    ████      ██████  ████████  </a:t>
+            </a:r>
+          </a:p>
+          <a:p>
+            <a:pPr algn="ctr">
+              <a:spcAft>
+                <a:spcPts val="0"/>
+              </a:spcAft>
+              <a:defRPr sz="1600">
+                <a:solidFill>
+                  <a:srgbClr val="58A6FF"/>
+                </a:solidFill>
+                <a:latin typeface="Consolas"/>
+              </a:defRPr>
+            </a:pPr>
+            <a:r>
+              <a:t>████  ████  ██    ██  ██        ██        </a:t>
+            </a:r>
+          </a:p>
+          <a:p>
+            <a:pPr algn="ctr">
+              <a:spcAft>
+                <a:spcPts val="0"/>
+              </a:spcAft>
+              <a:defRPr sz="1600">
+                <a:solidFill>
+                  <a:srgbClr val="58A6FF"/>
+                </a:solidFill>
+                <a:latin typeface="Consolas"/>
+              </a:defRPr>
+            </a:pPr>
+            <a:r>
+              <a:t>██  ██  ██  ████████  ██        ██████    </a:t>
+            </a:r>
+          </a:p>
+          <a:p>
+            <a:pPr algn="ctr">
+              <a:spcAft>
+                <a:spcPts val="0"/>
+              </a:spcAft>
+              <a:defRPr sz="1600">
+                <a:solidFill>
+                  <a:srgbClr val="58A6FF"/>
+                </a:solidFill>
+                <a:latin typeface="Consolas"/>
+              </a:defRPr>
+            </a:pPr>
+            <a:r>
+              <a:t>██      ██  ██    ██  ██        ██        </a:t>
+            </a:r>
+          </a:p>
+          <a:p>
+            <a:pPr algn="ctr">
+              <a:spcAft>
+                <a:spcPts val="0"/>
+              </a:spcAft>
+              <a:defRPr sz="1600">
+                <a:solidFill>
+                  <a:srgbClr val="58A6FF"/>
+                </a:solidFill>
+                <a:latin typeface="Consolas"/>
+              </a:defRPr>
+            </a:pPr>
+            <a:r>
+              <a:t>██      ██  ██    ██    ██████  ████████  </a:t>
+            </a:r>
+          </a:p>
+        </p:txBody>
+      </p:sp>
+      <p:sp>
+        <p:nvSpPr>
+          <p:cNvPr id="4" name="TextBox 3"/>
+          <p:cNvSpPr txBox="1"/>
+          <p:nvPr/>
+        </p:nvSpPr>
+        <p:spPr>
+          <a:xfrm>
+            <a:off x="731520" y="3749039"/>
+            <a:ext cx="7680960" cy="1828800"/>
+          </a:xfrm>
+          <a:prstGeom prst="rect">
+            <a:avLst/>
+          </a:prstGeom>
+          <a:noFill/>
+        </p:spPr>
+        <p:txBody>
+          <a:bodyPr wrap="none">
+            <a:spAutoFit/>
+          </a:bodyPr>
+          <a:lstStyle/>
+          <a:p>
+            <a:pPr algn="ctr">
+              <a:spcAft>
+                <a:spcPts val="0"/>
+              </a:spcAft>
+              <a:defRPr sz="1600">
+                <a:solidFill>
+                  <a:srgbClr val="8B949E"/>
+                </a:solidFill>
+                <a:latin typeface="Consolas"/>
+              </a:defRPr>
+            </a:pPr>
+            <a:r>
+              <a:t>────────────────────────────────────────────</a:t>
+            </a:r>
+          </a:p>
+          <a:p>
+            <a:pPr algn="ctr">
+              <a:spcAft>
+                <a:spcPts val="0"/>
+              </a:spcAft>
+              <a:defRPr sz="1600">
+                <a:solidFill>
+                  <a:srgbClr val="8B949E"/>
+                </a:solidFill>
+                <a:latin typeface="Consolas"/>
+              </a:defRPr>
+            </a:pPr>
+          </a:p>
+          <a:p>
+            <a:pPr algn="ctr">
+              <a:spcAft>
+                <a:spcPts val="0"/>
+              </a:spcAft>
+              <a:defRPr sz="1600">
+                <a:solidFill>
+                  <a:srgbClr val="58A6FF"/>
+                </a:solidFill>
+                <a:latin typeface="Consolas"/>
+              </a:defRPr>
+            </a:pPr>
+            <a:r>
+              <a:t>$ mace-gaussian run molecule.xyz</a:t>
+            </a:r>
+          </a:p>
+          <a:p>
+            <a:pPr algn="ctr">
+              <a:spcAft>
+                <a:spcPts val="0"/>
+              </a:spcAft>
+              <a:defRPr sz="1600">
+                <a:solidFill>
+                  <a:srgbClr val="8B949E"/>
+                </a:solidFill>
+                <a:latin typeface="Consolas"/>
+              </a:defRPr>
+            </a:pPr>
+          </a:p>
+          <a:p>
+            <a:pPr algn="ctr">
+              <a:spcAft>
+                <a:spcPts val="0"/>
+              </a:spcAft>
+              <a:defRPr sz="1600">
+                <a:solidFill>
+                  <a:srgbClr val="C9D1D9"/>
+                </a:solidFill>
+                <a:latin typeface="Consolas"/>
+              </a:defRPr>
+            </a:pPr>
+            <a:r>
+              <a:t>// ML-accelerated IR spectroscopy</a:t>
+            </a:r>
+          </a:p>
+          <a:p>
+            <a:pPr algn="ctr">
+              <a:spcAft>
+                <a:spcPts val="0"/>
+              </a:spcAft>
+              <a:defRPr sz="1600">
+                <a:solidFill>
+                  <a:srgbClr val="8B949E"/>
+                </a:solidFill>
+                <a:latin typeface="Consolas"/>
+              </a:defRPr>
+            </a:pPr>
+            <a:r>
+              <a:t>// MACE × Gaussian 16 · ZMQ · VPT2</a:t>
+            </a:r>
+          </a:p>
+        </p:txBody>
+      </p:sp>
+      <p:sp>
+        <p:nvSpPr>
+          <p:cNvPr id="5" name="TextBox 4"/>
           <p:cNvSpPr txBox="1"/>
           <p:nvPr/>
         </p:nvSpPr>

</xml_diff>

<commit_message>
feat(banners): style 9 — block font + GAUSSIAN, centered, minimal subtitle
Co-Authored-By: Claude Opus 4.6 <noreply@anthropic.com>
</commit_message>
<xml_diff>
--- a/presentation/banners/title_banners.pptx
+++ b/presentation/banners/title_banners.pptx
@@ -13,6 +13,7 @@
     <p:sldId id="261" r:id="rId12"/>
     <p:sldId id="262" r:id="rId13"/>
     <p:sldId id="263" r:id="rId14"/>
+    <p:sldId id="264" r:id="rId15"/>
   </p:sldIdLst>
   <p:sldSz cx="9144000" cy="6858000" type="screen4x3"/>
   <p:notesSz cx="6858000" cy="9144000"/>
@@ -5452,6 +5453,262 @@
             </a:pPr>
             <a:r>
               <a:t>// MACE × Gaussian 16 · ZMQ · VPT2</a:t>
+            </a:r>
+          </a:p>
+        </p:txBody>
+      </p:sp>
+      <p:sp>
+        <p:nvSpPr>
+          <p:cNvPr id="5" name="TextBox 4"/>
+          <p:cNvSpPr txBox="1"/>
+          <p:nvPr/>
+        </p:nvSpPr>
+        <p:spPr>
+          <a:xfrm>
+            <a:off x="914400" y="6263640"/>
+            <a:ext cx="7315200" cy="365760"/>
+          </a:xfrm>
+          <a:prstGeom prst="rect">
+            <a:avLst/>
+          </a:prstGeom>
+          <a:noFill/>
+        </p:spPr>
+        <p:txBody>
+          <a:bodyPr wrap="none">
+            <a:spAutoFit/>
+          </a:bodyPr>
+          <a:lstStyle/>
+          <a:p>
+            <a:pPr algn="ctr">
+              <a:defRPr sz="1100">
+                <a:solidFill>
+                  <a:srgbClr val="8B949E"/>
+                </a:solidFill>
+                <a:latin typeface="Consolas"/>
+              </a:defRPr>
+            </a:pPr>
+            <a:r>
+              <a:t>Manuel Ott · Hofer Lab · 2026-03-26</a:t>
+            </a:r>
+          </a:p>
+        </p:txBody>
+      </p:sp>
+    </p:spTree>
+  </p:cSld>
+  <p:clrMapOvr>
+    <a:masterClrMapping/>
+  </p:clrMapOvr>
+</p:sld>
+</file>
+
+<file path=ppt/slides/slide9.xml><?xml version="1.0" encoding="utf-8"?>
+<p:sld xmlns:a="http://schemas.openxmlformats.org/drawingml/2006/main" xmlns:p="http://schemas.openxmlformats.org/presentationml/2006/main" xmlns:r="http://schemas.openxmlformats.org/officeDocument/2006/relationships">
+  <p:cSld>
+    <p:bg>
+      <p:bgPr>
+        <a:solidFill>
+          <a:srgbClr val="0D1117"/>
+        </a:solidFill>
+        <a:effectLst/>
+      </p:bgPr>
+    </p:bg>
+    <p:spTree>
+      <p:nvGrpSpPr>
+        <p:cNvPr id="1" name=""/>
+        <p:cNvGrpSpPr/>
+        <p:nvPr/>
+      </p:nvGrpSpPr>
+      <p:grpSpPr/>
+      <p:sp>
+        <p:nvSpPr>
+          <p:cNvPr id="2" name="TextBox 1"/>
+          <p:cNvSpPr txBox="1"/>
+          <p:nvPr/>
+        </p:nvSpPr>
+        <p:spPr>
+          <a:xfrm>
+            <a:off x="457200" y="201168"/>
+            <a:ext cx="7315200" cy="274320"/>
+          </a:xfrm>
+          <a:prstGeom prst="rect">
+            <a:avLst/>
+          </a:prstGeom>
+          <a:noFill/>
+        </p:spPr>
+        <p:txBody>
+          <a:bodyPr wrap="none">
+            <a:spAutoFit/>
+          </a:bodyPr>
+          <a:lstStyle/>
+          <a:p>
+            <a:pPr>
+              <a:defRPr sz="1000">
+                <a:solidFill>
+                  <a:srgbClr val="8B949E"/>
+                </a:solidFill>
+                <a:latin typeface="Consolas"/>
+              </a:defRPr>
+            </a:pPr>
+            <a:r>
+              <a:t>// style 9 — block + GAUSSIAN — neofetch spirit</a:t>
+            </a:r>
+          </a:p>
+        </p:txBody>
+      </p:sp>
+      <p:sp>
+        <p:nvSpPr>
+          <p:cNvPr id="3" name="TextBox 2"/>
+          <p:cNvSpPr txBox="1"/>
+          <p:nvPr/>
+        </p:nvSpPr>
+        <p:spPr>
+          <a:xfrm>
+            <a:off x="548640" y="1463040"/>
+            <a:ext cx="8412480" cy="2743200"/>
+          </a:xfrm>
+          <a:prstGeom prst="rect">
+            <a:avLst/>
+          </a:prstGeom>
+          <a:noFill/>
+        </p:spPr>
+        <p:txBody>
+          <a:bodyPr wrap="none">
+            <a:spAutoFit/>
+          </a:bodyPr>
+          <a:lstStyle/>
+          <a:p>
+            <a:pPr algn="ctr">
+              <a:spcAft>
+                <a:spcPts val="0"/>
+              </a:spcAft>
+              <a:defRPr sz="1600">
+                <a:solidFill>
+                  <a:srgbClr val="58A6FF"/>
+                </a:solidFill>
+                <a:latin typeface="Consolas"/>
+              </a:defRPr>
+            </a:pPr>
+            <a:r>
+              <a:t>_|      _|    _|_|      _|_|_|  _|_|_|_|  </a:t>
+            </a:r>
+          </a:p>
+          <a:p>
+            <a:pPr algn="ctr">
+              <a:spcAft>
+                <a:spcPts val="0"/>
+              </a:spcAft>
+              <a:defRPr sz="1600">
+                <a:solidFill>
+                  <a:srgbClr val="58A6FF"/>
+                </a:solidFill>
+                <a:latin typeface="Consolas"/>
+              </a:defRPr>
+            </a:pPr>
+            <a:r>
+              <a:t>_|_|  _|_|  _|    _|  _|        _|        </a:t>
+            </a:r>
+          </a:p>
+          <a:p>
+            <a:pPr algn="ctr">
+              <a:spcAft>
+                <a:spcPts val="0"/>
+              </a:spcAft>
+              <a:defRPr sz="1600">
+                <a:solidFill>
+                  <a:srgbClr val="58A6FF"/>
+                </a:solidFill>
+                <a:latin typeface="Consolas"/>
+              </a:defRPr>
+            </a:pPr>
+            <a:r>
+              <a:t>_|  _|  _|  _|_|_|_|  _|        _|_|_|    </a:t>
+            </a:r>
+          </a:p>
+          <a:p>
+            <a:pPr algn="ctr">
+              <a:spcAft>
+                <a:spcPts val="0"/>
+              </a:spcAft>
+              <a:defRPr sz="1600">
+                <a:solidFill>
+                  <a:srgbClr val="58A6FF"/>
+                </a:solidFill>
+                <a:latin typeface="Consolas"/>
+              </a:defRPr>
+            </a:pPr>
+            <a:r>
+              <a:t>_|      _|  _|    _|  _|        _|        </a:t>
+            </a:r>
+          </a:p>
+          <a:p>
+            <a:pPr algn="ctr">
+              <a:spcAft>
+                <a:spcPts val="0"/>
+              </a:spcAft>
+              <a:defRPr sz="1600">
+                <a:solidFill>
+                  <a:srgbClr val="58A6FF"/>
+                </a:solidFill>
+                <a:latin typeface="Consolas"/>
+              </a:defRPr>
+            </a:pPr>
+            <a:r>
+              <a:t>_|      _|  _|    _|    _|_|_|  _|_|_|_|  </a:t>
+            </a:r>
+          </a:p>
+          <a:p>
+            <a:pPr algn="ctr">
+              <a:spcAft>
+                <a:spcPts val="0"/>
+              </a:spcAft>
+              <a:defRPr sz="1600">
+                <a:solidFill>
+                  <a:srgbClr val="58A6FF"/>
+                </a:solidFill>
+                <a:latin typeface="Consolas"/>
+              </a:defRPr>
+            </a:pPr>
+            <a:r>
+              <a:t>       GAUSSIAN</a:t>
+            </a:r>
+          </a:p>
+        </p:txBody>
+      </p:sp>
+      <p:sp>
+        <p:nvSpPr>
+          <p:cNvPr id="4" name="TextBox 3"/>
+          <p:cNvSpPr txBox="1"/>
+          <p:nvPr/>
+        </p:nvSpPr>
+        <p:spPr>
+          <a:xfrm>
+            <a:off x="731520" y="4572000"/>
+            <a:ext cx="7680960" cy="548640"/>
+          </a:xfrm>
+          <a:prstGeom prst="rect">
+            <a:avLst/>
+          </a:prstGeom>
+          <a:noFill/>
+        </p:spPr>
+        <p:txBody>
+          <a:bodyPr wrap="none">
+            <a:spAutoFit/>
+          </a:bodyPr>
+          <a:lstStyle/>
+          <a:p>
+            <a:pPr algn="ctr">
+              <a:spcAft>
+                <a:spcPts val="0"/>
+              </a:spcAft>
+              <a:defRPr sz="1600">
+                <a:solidFill>
+                  <a:srgbClr val="8B949E"/>
+                </a:solidFill>
+                <a:latin typeface="Consolas"/>
+              </a:defRPr>
+            </a:pPr>
+            <a:r>
+              <a:t>// ML-accelerated IR spectrum calculations</a:t>
             </a:r>
           </a:p>
         </p:txBody>

</xml_diff>

<commit_message>
feat(banners): style 9 — GAUSSIAN in green, aligned under the A
Co-Authored-By: Claude Opus 4.6 <noreply@anthropic.com>
</commit_message>
<xml_diff>
--- a/presentation/banners/title_banners.pptx
+++ b/presentation/banners/title_banners.pptx
@@ -5663,13 +5663,13 @@
               </a:spcAft>
               <a:defRPr sz="1600">
                 <a:solidFill>
-                  <a:srgbClr val="58A6FF"/>
-                </a:solidFill>
-                <a:latin typeface="Consolas"/>
-              </a:defRPr>
-            </a:pPr>
-            <a:r>
-              <a:t>       GAUSSIAN</a:t>
+                  <a:srgbClr val="3FB950"/>
+                </a:solidFill>
+                <a:latin typeface="Consolas"/>
+              </a:defRPr>
+            </a:pPr>
+            <a:r>
+              <a:t>              GAUSSIAN</a:t>
             </a:r>
           </a:p>
         </p:txBody>

</xml_diff>